<commit_message>
docs: add figures to results deck
scripts/build_results_figures.py generates paired light->dark slopegraph figures
from the committed analysis CSVs + behaviour JSON: the gauntlet (raw vs matched
MVL), MVL vs Skaggs MI (both matched-null), behaviour (coverage-vs-null +
occupancy entropy), and map engagement. Embedded into slides 5, 6, 9, 10 of
results-summary-deck.pptx.

Co-Authored-By: Claude Opus 4.8 (1M context) <noreply@anthropic.com>
</commit_message>
<xml_diff>
--- a/docs/manuscripts/results-summary-deck.pptx
+++ b/docs/manuscripts/results-summary-deck.pptx
@@ -3230,16 +3230,40 @@
           </a:p>
         </p:txBody>
       </p:sp>
-      <p:sp>
-        <p:nvSpPr>
-          <p:cNvPr id="3" name="TextBox 2"/>
+      <p:pic>
+        <p:nvPicPr>
+          <p:cNvPr id="3" name="Picture 2" descr="fig_map_engagement.png"/>
+          <p:cNvPicPr>
+            <a:picLocks noChangeAspect="1"/>
+          </p:cNvPicPr>
+          <p:nvPr/>
+        </p:nvPicPr>
+        <p:blipFill>
+          <a:blip r:embed="rId2"/>
+          <a:stretch>
+            <a:fillRect/>
+          </a:stretch>
+        </p:blipFill>
+        <p:spPr>
+          <a:xfrm>
+            <a:off x="7315200" y="1280160"/>
+            <a:ext cx="4572000" cy="4114173"/>
+          </a:xfrm>
+          <a:prstGeom prst="rect">
+            <a:avLst/>
+          </a:prstGeom>
+        </p:spPr>
+      </p:pic>
+      <p:sp>
+        <p:nvSpPr>
+          <p:cNvPr id="4" name="TextBox 3"/>
           <p:cNvSpPr txBox="1"/>
           <p:nvPr/>
         </p:nvSpPr>
         <p:spPr>
           <a:xfrm>
             <a:off x="548640" y="1188720"/>
-            <a:ext cx="11064240" cy="5303520"/>
+            <a:ext cx="6583680" cy="5303520"/>
           </a:xfrm>
           <a:prstGeom prst="rect">
             <a:avLst/>
@@ -3258,12 +3282,12 @@
               </a:spcAft>
             </a:pPr>
             <a:r>
-              <a:rPr sz="1800" b="0">
+              <a:rPr sz="1600" b="0">
                 <a:solidFill>
                   <a:srgbClr val="333333"/>
                 </a:solidFill>
               </a:rPr>
-              <a:t>• Test: does the same maze cell re-instantiate the same population state on each visit? (within- minus across-cell population-vector consistency, sampling matched, no decoding)</a:t>
+              <a:t>• Does the same maze cell re-instantiate the same population state on each visit? (within- minus across-cell population-vector consistency, sampling matched, no decoding)</a:t>
             </a:r>
           </a:p>
           <a:p>
@@ -3273,12 +3297,12 @@
               </a:spcAft>
             </a:pPr>
             <a:r>
-              <a:rPr sz="1800" b="1">
+              <a:rPr sz="1600" b="1">
                 <a:solidFill>
                   <a:srgbClr val="2D8B57"/>
                 </a:solidFill>
               </a:rPr>
-              <a:t>• Consistency is positive in nearly every session — a real spatial map exists</a:t>
+              <a:t>• Positive in nearly every session — a real spatial map exists</a:t>
             </a:r>
           </a:p>
           <a:p>
@@ -3288,12 +3312,12 @@
               </a:spcAft>
             </a:pPr>
             <a:r>
-              <a:rPr sz="1800" b="1">
+              <a:rPr sz="1600" b="1">
                 <a:solidFill>
                   <a:srgbClr val="1F4E79"/>
                 </a:solidFill>
               </a:rPr>
-              <a:t>• It does NOT differ light vs dark: 0.065 vs 0.062, p = 0.49 (12/21 sessions light&gt;dark)</a:t>
+              <a:t>• Does NOT differ light vs dark: 0.065 vs 0.062, p = 0.49</a:t>
             </a:r>
           </a:p>
           <a:p>
@@ -3303,7 +3327,7 @@
               </a:spcAft>
             </a:pPr>
             <a:r>
-              <a:rPr sz="1800" b="0">
+              <a:rPr sz="1600" b="0">
                 <a:solidFill>
                   <a:srgbClr val="333333"/>
                 </a:solidFill>
@@ -3318,12 +3342,12 @@
               </a:spcAft>
             </a:pPr>
             <a:r>
-              <a:rPr sz="1600" b="0">
+              <a:rPr sz="1400" b="0">
                 <a:solidFill>
                   <a:srgbClr val="666666"/>
                 </a:solidFill>
               </a:rPr>
-              <a:t>– Caveats: small/noisy measure (~20 ROIs, underpowered to prove equivalence); HD cells not excluded</a:t>
+              <a:t>– Caveat: small/noisy (~20 ROIs, underpowered to prove equivalence); HD cells not excluded</a:t>
             </a:r>
           </a:p>
         </p:txBody>
@@ -4307,358 +4331,30 @@
           </a:p>
         </p:txBody>
       </p:sp>
-      <p:graphicFrame>
-        <p:nvGraphicFramePr>
-          <p:cNvPr id="3" name="Table 2"/>
-          <p:cNvGraphicFramePr>
-            <a:graphicFrameLocks noGrp="1"/>
-          </p:cNvGraphicFramePr>
+      <p:pic>
+        <p:nvPicPr>
+          <p:cNvPr id="3" name="Picture 2" descr="fig_gauntlet.png"/>
+          <p:cNvPicPr>
+            <a:picLocks noChangeAspect="1"/>
+          </p:cNvPicPr>
           <p:nvPr/>
-        </p:nvGraphicFramePr>
-        <p:xfrm>
-          <a:off x="548640" y="1280160"/>
-          <a:ext cx="11064240" cy="1828800"/>
-        </p:xfrm>
-        <a:graphic>
-          <a:graphicData uri="http://schemas.openxmlformats.org/drawingml/2006/table">
-            <a:tbl>
-              <a:tblPr firstRow="1" bandRow="1">
-                <a:tableStyleId>{5C22544A-7EE6-4342-B048-85BDC9FD1C3A}</a:tableStyleId>
-              </a:tblPr>
-              <a:tblGrid>
-                <a:gridCol w="4572000"/>
-                <a:gridCol w="3657600"/>
-                <a:gridCol w="2834640"/>
-              </a:tblGrid>
-              <a:tr h="365760">
-                <a:tc>
-                  <a:txBody>
-                    <a:bodyPr/>
-                    <a:lstStyle/>
-                    <a:p>
-                      <a:r>
-                        <a:rPr sz="1400" b="1">
-                          <a:solidFill>
-                            <a:srgbClr val="FFFFFF"/>
-                          </a:solidFill>
-                        </a:rPr>
-                        <a:t>Control</a:t>
-                      </a:r>
-                    </a:p>
-                  </a:txBody>
-                  <a:tcPr>
-                    <a:solidFill>
-                      <a:srgbClr val="2E75B6"/>
-                    </a:solidFill>
-                  </a:tcPr>
-                </a:tc>
-                <a:tc>
-                  <a:txBody>
-                    <a:bodyPr/>
-                    <a:lstStyle/>
-                    <a:p>
-                      <a:r>
-                        <a:rPr sz="1400" b="1">
-                          <a:solidFill>
-                            <a:srgbClr val="FFFFFF"/>
-                          </a:solidFill>
-                        </a:rPr>
-                        <a:t>Light vs dark (MVL)</a:t>
-                      </a:r>
-                    </a:p>
-                  </a:txBody>
-                  <a:tcPr>
-                    <a:solidFill>
-                      <a:srgbClr val="2E75B6"/>
-                    </a:solidFill>
-                  </a:tcPr>
-                </a:tc>
-                <a:tc>
-                  <a:txBody>
-                    <a:bodyPr/>
-                    <a:lstStyle/>
-                    <a:p>
-                      <a:r>
-                        <a:rPr sz="1400" b="1">
-                          <a:solidFill>
-                            <a:srgbClr val="FFFFFF"/>
-                          </a:solidFill>
-                        </a:rPr>
-                        <a:t>Verdict</a:t>
-                      </a:r>
-                    </a:p>
-                  </a:txBody>
-                  <a:tcPr>
-                    <a:solidFill>
-                      <a:srgbClr val="2E75B6"/>
-                    </a:solidFill>
-                  </a:tcPr>
-                </a:tc>
-              </a:tr>
-              <a:tr h="365760">
-                <a:tc>
-                  <a:txBody>
-                    <a:bodyPr/>
-                    <a:lstStyle/>
-                    <a:p>
-                      <a:r>
-                        <a:rPr sz="1400">
-                          <a:solidFill>
-                            <a:srgbClr val="333333"/>
-                          </a:solidFill>
-                        </a:rPr>
-                        <a:t>Raw (no matching)</a:t>
-                      </a:r>
-                    </a:p>
-                  </a:txBody>
-                  <a:tcPr>
-                    <a:solidFill>
-                      <a:srgbClr val="FFFFFF"/>
-                    </a:solidFill>
-                  </a:tcPr>
-                </a:tc>
-                <a:tc>
-                  <a:txBody>
-                    <a:bodyPr/>
-                    <a:lstStyle/>
-                    <a:p>
-                      <a:r>
-                        <a:rPr sz="1400">
-                          <a:solidFill>
-                            <a:srgbClr val="333333"/>
-                          </a:solidFill>
-                        </a:rPr>
-                        <a:t>p = 0.0010</a:t>
-                      </a:r>
-                    </a:p>
-                  </a:txBody>
-                  <a:tcPr>
-                    <a:solidFill>
-                      <a:srgbClr val="FFFFFF"/>
-                    </a:solidFill>
-                  </a:tcPr>
-                </a:tc>
-                <a:tc>
-                  <a:txBody>
-                    <a:bodyPr/>
-                    <a:lstStyle/>
-                    <a:p>
-                      <a:r>
-                        <a:rPr sz="1400">
-                          <a:solidFill>
-                            <a:srgbClr val="2D8B57"/>
-                          </a:solidFill>
-                        </a:rPr>
-                        <a:t>dark &gt; light</a:t>
-                      </a:r>
-                    </a:p>
-                  </a:txBody>
-                  <a:tcPr>
-                    <a:solidFill>
-                      <a:srgbClr val="FFFFFF"/>
-                    </a:solidFill>
-                  </a:tcPr>
-                </a:tc>
-              </a:tr>
-              <a:tr h="365760">
-                <a:tc>
-                  <a:txBody>
-                    <a:bodyPr/>
-                    <a:lstStyle/>
-                    <a:p>
-                      <a:r>
-                        <a:rPr sz="1400">
-                          <a:solidFill>
-                            <a:srgbClr val="333333"/>
-                          </a:solidFill>
-                        </a:rPr>
-                        <a:t>A1 occupancy-matched</a:t>
-                      </a:r>
-                    </a:p>
-                  </a:txBody>
-                  <a:tcPr>
-                    <a:solidFill>
-                      <a:srgbClr val="F2F2F2"/>
-                    </a:solidFill>
-                  </a:tcPr>
-                </a:tc>
-                <a:tc>
-                  <a:txBody>
-                    <a:bodyPr/>
-                    <a:lstStyle/>
-                    <a:p>
-                      <a:r>
-                        <a:rPr sz="1400">
-                          <a:solidFill>
-                            <a:srgbClr val="333333"/>
-                          </a:solidFill>
-                        </a:rPr>
-                        <a:t>p = 0.16</a:t>
-                      </a:r>
-                    </a:p>
-                  </a:txBody>
-                  <a:tcPr>
-                    <a:solidFill>
-                      <a:srgbClr val="F2F2F2"/>
-                    </a:solidFill>
-                  </a:tcPr>
-                </a:tc>
-                <a:tc>
-                  <a:txBody>
-                    <a:bodyPr/>
-                    <a:lstStyle/>
-                    <a:p>
-                      <a:r>
-                        <a:rPr sz="1400">
-                          <a:solidFill>
-                            <a:srgbClr val="C0392B"/>
-                          </a:solidFill>
-                        </a:rPr>
-                        <a:t>not significant</a:t>
-                      </a:r>
-                    </a:p>
-                  </a:txBody>
-                  <a:tcPr>
-                    <a:solidFill>
-                      <a:srgbClr val="F2F2F2"/>
-                    </a:solidFill>
-                  </a:tcPr>
-                </a:tc>
-              </a:tr>
-              <a:tr h="365760">
-                <a:tc>
-                  <a:txBody>
-                    <a:bodyPr/>
-                    <a:lstStyle/>
-                    <a:p>
-                      <a:r>
-                        <a:rPr sz="1400">
-                          <a:solidFill>
-                            <a:srgbClr val="333333"/>
-                          </a:solidFill>
-                        </a:rPr>
-                        <a:t>A2 speed+|AHV|-matched</a:t>
-                      </a:r>
-                    </a:p>
-                  </a:txBody>
-                  <a:tcPr>
-                    <a:solidFill>
-                      <a:srgbClr val="FFFFFF"/>
-                    </a:solidFill>
-                  </a:tcPr>
-                </a:tc>
-                <a:tc>
-                  <a:txBody>
-                    <a:bodyPr/>
-                    <a:lstStyle/>
-                    <a:p>
-                      <a:r>
-                        <a:rPr sz="1400">
-                          <a:solidFill>
-                            <a:srgbClr val="333333"/>
-                          </a:solidFill>
-                        </a:rPr>
-                        <a:t>p = 0.25</a:t>
-                      </a:r>
-                    </a:p>
-                  </a:txBody>
-                  <a:tcPr>
-                    <a:solidFill>
-                      <a:srgbClr val="FFFFFF"/>
-                    </a:solidFill>
-                  </a:tcPr>
-                </a:tc>
-                <a:tc>
-                  <a:txBody>
-                    <a:bodyPr/>
-                    <a:lstStyle/>
-                    <a:p>
-                      <a:r>
-                        <a:rPr sz="1400">
-                          <a:solidFill>
-                            <a:srgbClr val="C0392B"/>
-                          </a:solidFill>
-                        </a:rPr>
-                        <a:t>not significant</a:t>
-                      </a:r>
-                    </a:p>
-                  </a:txBody>
-                  <a:tcPr>
-                    <a:solidFill>
-                      <a:srgbClr val="FFFFFF"/>
-                    </a:solidFill>
-                  </a:tcPr>
-                </a:tc>
-              </a:tr>
-              <a:tr h="365760">
-                <a:tc>
-                  <a:txBody>
-                    <a:bodyPr/>
-                    <a:lstStyle/>
-                    <a:p>
-                      <a:r>
-                        <a:rPr sz="1400">
-                          <a:solidFill>
-                            <a:srgbClr val="333333"/>
-                          </a:solidFill>
-                        </a:rPr>
-                        <a:t>A3 epoch-order / bleaching</a:t>
-                      </a:r>
-                    </a:p>
-                  </a:txBody>
-                  <a:tcPr>
-                    <a:solidFill>
-                      <a:srgbClr val="F2F2F2"/>
-                    </a:solidFill>
-                  </a:tcPr>
-                </a:tc>
-                <a:tc>
-                  <a:txBody>
-                    <a:bodyPr/>
-                    <a:lstStyle/>
-                    <a:p>
-                      <a:r>
-                        <a:rPr sz="1400">
-                          <a:solidFill>
-                            <a:srgbClr val="333333"/>
-                          </a:solidFill>
-                        </a:rPr>
-                        <a:t>p = 0.10</a:t>
-                      </a:r>
-                    </a:p>
-                  </a:txBody>
-                  <a:tcPr>
-                    <a:solidFill>
-                      <a:srgbClr val="F2F2F2"/>
-                    </a:solidFill>
-                  </a:tcPr>
-                </a:tc>
-                <a:tc>
-                  <a:txBody>
-                    <a:bodyPr/>
-                    <a:lstStyle/>
-                    <a:p>
-                      <a:r>
-                        <a:rPr sz="1400">
-                          <a:solidFill>
-                            <a:srgbClr val="C0392B"/>
-                          </a:solidFill>
-                        </a:rPr>
-                        <a:t>not significant</a:t>
-                      </a:r>
-                    </a:p>
-                  </a:txBody>
-                  <a:tcPr>
-                    <a:solidFill>
-                      <a:srgbClr val="F2F2F2"/>
-                    </a:solidFill>
-                  </a:tcPr>
-                </a:tc>
-              </a:tr>
-            </a:tbl>
-          </a:graphicData>
-        </a:graphic>
-      </p:graphicFrame>
+        </p:nvPicPr>
+        <p:blipFill>
+          <a:blip r:embed="rId2"/>
+          <a:stretch>
+            <a:fillRect/>
+          </a:stretch>
+        </p:blipFill>
+        <p:spPr>
+          <a:xfrm>
+            <a:off x="2441448" y="1005840"/>
+            <a:ext cx="7315200" cy="4292832"/>
+          </a:xfrm>
+          <a:prstGeom prst="rect">
+            <a:avLst/>
+          </a:prstGeom>
+        </p:spPr>
+      </p:pic>
       <p:sp>
         <p:nvSpPr>
           <p:cNvPr id="4" name="TextBox 3"/>
@@ -4667,7 +4363,7 @@
         </p:nvSpPr>
         <p:spPr>
           <a:xfrm>
-            <a:off x="548640" y="4206240"/>
+            <a:off x="548640" y="5440680"/>
             <a:ext cx="11064240" cy="5303520"/>
           </a:xfrm>
           <a:prstGeom prst="rect">
@@ -4687,12 +4383,12 @@
               </a:spcAft>
             </a:pPr>
             <a:r>
-              <a:rPr sz="1800" b="0">
-                <a:solidFill>
-                  <a:srgbClr val="333333"/>
-                </a:solidFill>
-              </a:rPr>
-              <a:t>• Equalising how the mouse samples head direction removes the effect</a:t>
+              <a:rPr sz="1500" b="0">
+                <a:solidFill>
+                  <a:srgbClr val="666666"/>
+                </a:solidFill>
+              </a:rPr>
+              <a:t>• Each line = one session (light → dark); red bars = condition medians</a:t>
             </a:r>
           </a:p>
           <a:p>
@@ -4702,12 +4398,12 @@
               </a:spcAft>
             </a:pPr>
             <a:r>
-              <a:rPr sz="1800" b="1">
+              <a:rPr sz="1500" b="1">
                 <a:solidFill>
                   <a:srgbClr val="1F4E79"/>
                 </a:solidFill>
               </a:rPr>
-              <a:t>• The raw dark&gt;light MVL is largely differential sampling, not a coding gain</a:t>
+              <a:t>• Raw: dark &gt; light (p = 0.001). After matching HD sampling: n.s. (A1 p = 0.16, A2 p = 0.25)</a:t>
             </a:r>
           </a:p>
         </p:txBody>
@@ -4814,16 +4510,40 @@
           </a:p>
         </p:txBody>
       </p:sp>
-      <p:sp>
-        <p:nvSpPr>
-          <p:cNvPr id="3" name="TextBox 2"/>
+      <p:pic>
+        <p:nvPicPr>
+          <p:cNvPr id="3" name="Picture 2" descr="fig_mvl_vs_mi.png"/>
+          <p:cNvPicPr>
+            <a:picLocks noChangeAspect="1"/>
+          </p:cNvPicPr>
+          <p:nvPr/>
+        </p:nvPicPr>
+        <p:blipFill>
+          <a:blip r:embed="rId2"/>
+          <a:stretch>
+            <a:fillRect/>
+          </a:stretch>
+        </p:blipFill>
+        <p:spPr>
+          <a:xfrm>
+            <a:off x="4297680" y="1188720"/>
+            <a:ext cx="7589520" cy="4369930"/>
+          </a:xfrm>
+          <a:prstGeom prst="rect">
+            <a:avLst/>
+          </a:prstGeom>
+        </p:spPr>
+      </p:pic>
+      <p:sp>
+        <p:nvSpPr>
+          <p:cNvPr id="4" name="TextBox 3"/>
           <p:cNvSpPr txBox="1"/>
           <p:nvPr/>
         </p:nvSpPr>
         <p:spPr>
           <a:xfrm>
             <a:off x="548640" y="1188720"/>
-            <a:ext cx="11064240" cy="5303520"/>
+            <a:ext cx="3840480" cy="5303520"/>
           </a:xfrm>
           <a:prstGeom prst="rect">
             <a:avLst/>
@@ -4842,12 +4562,27 @@
               </a:spcAft>
             </a:pPr>
             <a:r>
-              <a:rPr sz="1800" b="0">
+              <a:rPr sz="1500" b="0">
                 <a:solidFill>
                   <a:srgbClr val="333333"/>
                 </a:solidFill>
               </a:rPr>
-              <a:t>• Skaggs head-direction information (bits/event; Voigts &amp; Harnett 2020, Zong et al. 2022) run through the same matched gauntlet</a:t>
+              <a:t>• Skaggs HD information (bits/event; Voigts &amp; Harnett 2020, Zong 2022) through the same matched gauntlet</a:t>
+            </a:r>
+          </a:p>
+          <a:p>
+            <a:pPr lvl="1">
+              <a:spcAft>
+                <a:spcPts val="600"/>
+              </a:spcAft>
+            </a:pPr>
+            <a:r>
+              <a:rPr sz="1300" b="0">
+                <a:solidFill>
+                  <a:srgbClr val="333333"/>
+                </a:solidFill>
+              </a:rPr>
+              <a:t>– Matched HD-MI is null, more emphatically than MVL (A1 p = 0.64)</a:t>
             </a:r>
           </a:p>
           <a:p>
@@ -4857,12 +4592,12 @@
               </a:spcAft>
             </a:pPr>
             <a:r>
-              <a:rPr sz="1800" b="0">
+              <a:rPr sz="1500" b="0">
                 <a:solidFill>
                   <a:srgbClr val="333333"/>
                 </a:solidFill>
               </a:rPr>
-              <a:t>• Matched HD-MI is null, more emphatically than MVL: A1 p = 0.64, A2 p = 0.89</a:t>
+              <a:t>• Place information also dies under position-occupancy matching (p = 0.15)</a:t>
             </a:r>
           </a:p>
           <a:p>
@@ -4872,12 +4607,12 @@
               </a:spcAft>
             </a:pPr>
             <a:r>
-              <a:rPr sz="1800" b="0">
+              <a:rPr sz="1500" b="0">
                 <a:solidFill>
                   <a:srgbClr val="333333"/>
                 </a:solidFill>
               </a:rPr>
-              <a:t>• Place (spatial) information also dies under position-occupancy matching (p = 0.15)</a:t>
+              <a:t>• Secondary 'gain' and dark cell-recruitment signals also collapse under matching</a:t>
             </a:r>
           </a:p>
           <a:p>
@@ -4887,27 +4622,12 @@
               </a:spcAft>
             </a:pPr>
             <a:r>
-              <a:rPr sz="1800" b="0">
-                <a:solidFill>
-                  <a:srgbClr val="333333"/>
-                </a:solidFill>
-              </a:rPr>
-              <a:t>• Secondary signals collapse too: the apparent 'gain' does not survive (matched p = 0.21); the apparent dark cell-recruitment reverses to favour light</a:t>
-            </a:r>
-          </a:p>
-          <a:p>
-            <a:pPr>
-              <a:spcAft>
-                <a:spcPts val="600"/>
-              </a:spcAft>
-            </a:pPr>
-            <a:r>
-              <a:rPr sz="1800" b="1">
+              <a:rPr sz="1500" b="1">
                 <a:solidFill>
                   <a:srgbClr val="1F4E79"/>
                 </a:solidFill>
               </a:rPr>
-              <a:t>• Two independent metrics give the same answer: no dark enhancement of HD or place coding survives matching</a:t>
+              <a:t>• Two metrics, same answer: no dark enhancement of HD or place coding survives</a:t>
             </a:r>
           </a:p>
         </p:txBody>
@@ -5799,17 +5519,41 @@
           </a:p>
         </p:txBody>
       </p:sp>
+      <p:pic>
+        <p:nvPicPr>
+          <p:cNvPr id="3" name="Picture 2" descr="fig_behaviour.png"/>
+          <p:cNvPicPr>
+            <a:picLocks noChangeAspect="1"/>
+          </p:cNvPicPr>
+          <p:nvPr/>
+        </p:nvPicPr>
+        <p:blipFill>
+          <a:blip r:embed="rId2"/>
+          <a:stretch>
+            <a:fillRect/>
+          </a:stretch>
+        </p:blipFill>
+        <p:spPr>
+          <a:xfrm>
+            <a:off x="4480560" y="1188720"/>
+            <a:ext cx="7406640" cy="4264630"/>
+          </a:xfrm>
+          <a:prstGeom prst="rect">
+            <a:avLst/>
+          </a:prstGeom>
+        </p:spPr>
+      </p:pic>
       <p:graphicFrame>
         <p:nvGraphicFramePr>
-          <p:cNvPr id="3" name="Table 2"/>
+          <p:cNvPr id="4" name="Table 3"/>
           <p:cNvGraphicFramePr>
             <a:graphicFrameLocks noGrp="1"/>
           </p:cNvGraphicFramePr>
           <p:nvPr/>
         </p:nvGraphicFramePr>
         <p:xfrm>
-          <a:off x="548640" y="1280160"/>
-          <a:ext cx="11064240" cy="1828800"/>
+          <a:off x="457200" y="1371600"/>
+          <a:ext cx="3931920" cy="1828800"/>
         </p:xfrm>
         <a:graphic>
           <a:graphicData uri="http://schemas.openxmlformats.org/drawingml/2006/table">
@@ -5818,10 +5562,10 @@
                 <a:tableStyleId>{5C22544A-7EE6-4342-B048-85BDC9FD1C3A}</a:tableStyleId>
               </a:tblPr>
               <a:tblGrid>
-                <a:gridCol w="4937760"/>
-                <a:gridCol w="1828800"/>
-                <a:gridCol w="1828800"/>
-                <a:gridCol w="2468880"/>
+                <a:gridCol w="1920240"/>
+                <a:gridCol w="640080"/>
+                <a:gridCol w="640080"/>
+                <a:gridCol w="731520"/>
               </a:tblGrid>
               <a:tr h="365760">
                 <a:tc>
@@ -5830,7 +5574,7 @@
                     <a:lstStyle/>
                     <a:p>
                       <a:r>
-                        <a:rPr sz="1400" b="1">
+                        <a:rPr sz="1200" b="1">
                           <a:solidFill>
                             <a:srgbClr val="FFFFFF"/>
                           </a:solidFill>
@@ -5851,12 +5595,12 @@
                     <a:lstStyle/>
                     <a:p>
                       <a:r>
-                        <a:rPr sz="1400" b="1">
+                        <a:rPr sz="1200" b="1">
                           <a:solidFill>
                             <a:srgbClr val="FFFFFF"/>
                           </a:solidFill>
                         </a:rPr>
-                        <a:t>Light</a:t>
+                        <a:t>L</a:t>
                       </a:r>
                     </a:p>
                   </a:txBody>
@@ -5872,12 +5616,12 @@
                     <a:lstStyle/>
                     <a:p>
                       <a:r>
-                        <a:rPr sz="1400" b="1">
+                        <a:rPr sz="1200" b="1">
                           <a:solidFill>
                             <a:srgbClr val="FFFFFF"/>
                           </a:solidFill>
                         </a:rPr>
-                        <a:t>Dark</a:t>
+                        <a:t>D</a:t>
                       </a:r>
                     </a:p>
                   </a:txBody>
@@ -5893,12 +5637,12 @@
                     <a:lstStyle/>
                     <a:p>
                       <a:r>
-                        <a:rPr sz="1400" b="1">
+                        <a:rPr sz="1200" b="1">
                           <a:solidFill>
                             <a:srgbClr val="FFFFFF"/>
                           </a:solidFill>
                         </a:rPr>
-                        <a:t>Corrected p</a:t>
+                        <a:t>p_adj</a:t>
                       </a:r>
                     </a:p>
                   </a:txBody>
@@ -5916,12 +5660,12 @@
                     <a:lstStyle/>
                     <a:p>
                       <a:r>
-                        <a:rPr sz="1400">
+                        <a:rPr sz="1200">
                           <a:solidFill>
                             <a:srgbClr val="333333"/>
                           </a:solidFill>
                         </a:rPr>
-                        <a:t>Coverage (unique cells/min)</a:t>
+                        <a:t>Coverage (cells/min)</a:t>
                       </a:r>
                     </a:p>
                   </a:txBody>
@@ -5937,7 +5681,7 @@
                     <a:lstStyle/>
                     <a:p>
                       <a:r>
-                        <a:rPr sz="1400">
+                        <a:rPr sz="1200">
                           <a:solidFill>
                             <a:srgbClr val="333333"/>
                           </a:solidFill>
@@ -5958,7 +5702,7 @@
                     <a:lstStyle/>
                     <a:p>
                       <a:r>
-                        <a:rPr sz="1400">
+                        <a:rPr sz="1200">
                           <a:solidFill>
                             <a:srgbClr val="333333"/>
                           </a:solidFill>
@@ -5979,7 +5723,7 @@
                     <a:lstStyle/>
                     <a:p>
                       <a:r>
-                        <a:rPr sz="1400">
+                        <a:rPr sz="1200">
                           <a:solidFill>
                             <a:srgbClr val="2D8B57"/>
                           </a:solidFill>
@@ -6002,12 +5746,12 @@
                     <a:lstStyle/>
                     <a:p>
                       <a:r>
-                        <a:rPr sz="1400">
+                        <a:rPr sz="1200">
                           <a:solidFill>
                             <a:srgbClr val="333333"/>
                           </a:solidFill>
                         </a:rPr>
-                        <a:t>Occupancy entropy (bits)</a:t>
+                        <a:t>Occupancy entropy</a:t>
                       </a:r>
                     </a:p>
                   </a:txBody>
@@ -6023,7 +5767,7 @@
                     <a:lstStyle/>
                     <a:p>
                       <a:r>
-                        <a:rPr sz="1400">
+                        <a:rPr sz="1200">
                           <a:solidFill>
                             <a:srgbClr val="333333"/>
                           </a:solidFill>
@@ -6044,7 +5788,7 @@
                     <a:lstStyle/>
                     <a:p>
                       <a:r>
-                        <a:rPr sz="1400">
+                        <a:rPr sz="1200">
                           <a:solidFill>
                             <a:srgbClr val="333333"/>
                           </a:solidFill>
@@ -6065,7 +5809,7 @@
                     <a:lstStyle/>
                     <a:p>
                       <a:r>
-                        <a:rPr sz="1400">
+                        <a:rPr sz="1200">
                           <a:solidFill>
                             <a:srgbClr val="2D8B57"/>
                           </a:solidFill>
@@ -6088,12 +5832,12 @@
                     <a:lstStyle/>
                     <a:p>
                       <a:r>
-                        <a:rPr sz="1400">
+                        <a:rPr sz="1200">
                           <a:solidFill>
                             <a:srgbClr val="333333"/>
                           </a:solidFill>
                         </a:rPr>
-                        <a:t>Coverage vs random-walk null (z)</a:t>
+                        <a:t>Coverage vs null (z)</a:t>
                       </a:r>
                     </a:p>
                   </a:txBody>
@@ -6109,7 +5853,7 @@
                     <a:lstStyle/>
                     <a:p>
                       <a:r>
-                        <a:rPr sz="1400">
+                        <a:rPr sz="1200">
                           <a:solidFill>
                             <a:srgbClr val="333333"/>
                           </a:solidFill>
@@ -6130,7 +5874,7 @@
                     <a:lstStyle/>
                     <a:p>
                       <a:r>
-                        <a:rPr sz="1400">
+                        <a:rPr sz="1200">
                           <a:solidFill>
                             <a:srgbClr val="333333"/>
                           </a:solidFill>
@@ -6151,7 +5895,7 @@
                     <a:lstStyle/>
                     <a:p>
                       <a:r>
-                        <a:rPr sz="1400">
+                        <a:rPr sz="1200">
                           <a:solidFill>
                             <a:srgbClr val="2D8B57"/>
                           </a:solidFill>
@@ -6174,12 +5918,12 @@
                     <a:lstStyle/>
                     <a:p>
                       <a:r>
-                        <a:rPr sz="1400">
+                        <a:rPr sz="1200">
                           <a:solidFill>
                             <a:srgbClr val="333333"/>
                           </a:solidFill>
                         </a:rPr>
-                        <a:t>Route compressibility (LZ)</a:t>
+                        <a:t>Route LZ</a:t>
                       </a:r>
                     </a:p>
                   </a:txBody>
@@ -6195,7 +5939,7 @@
                     <a:lstStyle/>
                     <a:p>
                       <a:r>
-                        <a:rPr sz="1400">
+                        <a:rPr sz="1200">
                           <a:solidFill>
                             <a:srgbClr val="333333"/>
                           </a:solidFill>
@@ -6216,7 +5960,7 @@
                     <a:lstStyle/>
                     <a:p>
                       <a:r>
-                        <a:rPr sz="1400">
+                        <a:rPr sz="1200">
                           <a:solidFill>
                             <a:srgbClr val="333333"/>
                           </a:solidFill>
@@ -6237,12 +5981,12 @@
                     <a:lstStyle/>
                     <a:p>
                       <a:r>
-                        <a:rPr sz="1400">
+                        <a:rPr sz="1200">
                           <a:solidFill>
                             <a:srgbClr val="666666"/>
                           </a:solidFill>
                         </a:rPr>
-                        <a:t>0.85 (ns)</a:t>
+                        <a:t>0.85</a:t>
                       </a:r>
                     </a:p>
                   </a:txBody>
@@ -6259,14 +6003,14 @@
       </p:graphicFrame>
       <p:sp>
         <p:nvSpPr>
-          <p:cNvPr id="4" name="TextBox 3"/>
+          <p:cNvPr id="5" name="TextBox 4"/>
           <p:cNvSpPr txBox="1"/>
           <p:nvPr/>
         </p:nvSpPr>
         <p:spPr>
           <a:xfrm>
-            <a:off x="548640" y="3657600"/>
-            <a:ext cx="11064240" cy="5303520"/>
+            <a:off x="457200" y="3840480"/>
+            <a:ext cx="3931920" cy="5303520"/>
           </a:xfrm>
           <a:prstGeom prst="rect">
             <a:avLst/>
@@ -6285,7 +6029,7 @@
               </a:spcAft>
             </a:pPr>
             <a:r>
-              <a:rPr sz="1800" b="1">
+              <a:rPr sz="1400" b="1">
                 <a:solidFill>
                   <a:srgbClr val="1F4E79"/>
                 </a:solidFill>
@@ -6300,12 +6044,12 @@
               </a:spcAft>
             </a:pPr>
             <a:r>
-              <a:rPr sz="1800" b="1">
+              <a:rPr sz="1400" b="1">
                 <a:solidFill>
                   <a:srgbClr val="1F4E79"/>
                 </a:solidFill>
               </a:rPr>
-              <a:t>• In dark they fall to near random-walk level, controlling for how much they moved and the maze shape</a:t>
+              <a:t>• In dark they fall to near random-walk level, controlling for distance moved and maze shape</a:t>
             </a:r>
           </a:p>
           <a:p>
@@ -6315,12 +6059,12 @@
               </a:spcAft>
             </a:pPr>
             <a:r>
-              <a:rPr sz="1600" b="0">
+              <a:rPr sz="1200" b="0">
                 <a:solidFill>
                   <a:srgbClr val="666666"/>
                 </a:solidFill>
               </a:rPr>
-              <a:t>– Local route patterns are unchanged (LZ) — they don't run tighter loops; they stop steering toward new ground</a:t>
+              <a:t>– Route patterns unchanged (LZ) — they stop steering toward new ground, not running tighter loops</a:t>
             </a:r>
           </a:p>
         </p:txBody>

</xml_diff>